<commit_message>
Add the three approved tool photos to slide 2
Charlie's shots of the actual tools at the brakes, replacing the
placeholder: switchable magnet on the die, Fulton orange push bar
(marked PB 11), and the offset-jaw tongs. Cropped to a common 2.49:1
and captioned 1 / 2 / 3 to match the method cards above them.

The push bar photo was shot upside down; rotated 180 so FULTON and the
PB 11 marking read correctly.

Slide 2 retimed to fit the photo row: rule box and method cards tightened,
photos at y3.98, verification block moved up to y5.88. Both slides still
clear the footer and validate clean.

Co-Authored-By: Claude Opus 5 <noreply@anthropic.com>
Claude-Session: https://claude.ai/code/session_01D8CDGEMSTJmpvRsZMfYmLM
</commit_message>
<xml_diff>
--- a/comms/press-brake-no-hands.pptx
+++ b/comms/press-brake-no-hands.pptx
@@ -2460,8 +2460,8 @@
         </p:nvSpPr>
         <p:spPr>
           <a:xfrm>
-            <a:off x="411480" y="1444752"/>
-            <a:ext cx="11375136" cy="749808"/>
+            <a:off x="411480" y="1371600"/>
+            <a:ext cx="11375136" cy="676656"/>
           </a:xfrm>
           <a:prstGeom prst="rect">
             <a:avLst/>
@@ -2485,8 +2485,8 @@
         </p:nvSpPr>
         <p:spPr>
           <a:xfrm>
-            <a:off x="603504" y="1517904"/>
-            <a:ext cx="10972800" cy="310896"/>
+            <a:off x="603504" y="1435608"/>
+            <a:ext cx="10972800" cy="292608"/>
           </a:xfrm>
           <a:prstGeom prst="rect">
             <a:avLst/>
@@ -2524,8 +2524,8 @@
         </p:nvSpPr>
         <p:spPr>
           <a:xfrm>
-            <a:off x="603504" y="1828800"/>
-            <a:ext cx="10972800" cy="256032"/>
+            <a:off x="603504" y="1737360"/>
+            <a:ext cx="10972800" cy="237744"/>
           </a:xfrm>
           <a:prstGeom prst="rect">
             <a:avLst/>
@@ -2563,8 +2563,8 @@
         </p:nvSpPr>
         <p:spPr>
           <a:xfrm>
-            <a:off x="411480" y="2359152"/>
-            <a:ext cx="2715768" cy="1481328"/>
+            <a:off x="411480" y="2121408"/>
+            <a:ext cx="2715768" cy="1371600"/>
           </a:xfrm>
           <a:prstGeom prst="rect">
             <a:avLst/>
@@ -2588,7 +2588,7 @@
         </p:nvSpPr>
         <p:spPr>
           <a:xfrm>
-            <a:off x="557784" y="2432304"/>
+            <a:off x="557784" y="2194560"/>
             <a:ext cx="548640" cy="274320"/>
           </a:xfrm>
           <a:prstGeom prst="rect">
@@ -2627,7 +2627,7 @@
         </p:nvSpPr>
         <p:spPr>
           <a:xfrm>
-            <a:off x="557784" y="2706624"/>
+            <a:off x="557784" y="2468880"/>
             <a:ext cx="2423160" cy="237744"/>
           </a:xfrm>
           <a:prstGeom prst="rect">
@@ -2666,7 +2666,7 @@
         </p:nvSpPr>
         <p:spPr>
           <a:xfrm>
-            <a:off x="557784" y="2962656"/>
+            <a:off x="557784" y="2724912"/>
             <a:ext cx="2423160" cy="804672"/>
           </a:xfrm>
           <a:prstGeom prst="rect">
@@ -2734,8 +2734,8 @@
         </p:nvSpPr>
         <p:spPr>
           <a:xfrm>
-            <a:off x="3300984" y="2359152"/>
-            <a:ext cx="2715768" cy="1481328"/>
+            <a:off x="3300984" y="2121408"/>
+            <a:ext cx="2715768" cy="1371600"/>
           </a:xfrm>
           <a:prstGeom prst="rect">
             <a:avLst/>
@@ -2759,7 +2759,7 @@
         </p:nvSpPr>
         <p:spPr>
           <a:xfrm>
-            <a:off x="3447288" y="2432304"/>
+            <a:off x="3447288" y="2194560"/>
             <a:ext cx="548640" cy="274320"/>
           </a:xfrm>
           <a:prstGeom prst="rect">
@@ -2798,7 +2798,7 @@
         </p:nvSpPr>
         <p:spPr>
           <a:xfrm>
-            <a:off x="3447288" y="2706624"/>
+            <a:off x="3447288" y="2468880"/>
             <a:ext cx="2423160" cy="237744"/>
           </a:xfrm>
           <a:prstGeom prst="rect">
@@ -2837,7 +2837,7 @@
         </p:nvSpPr>
         <p:spPr>
           <a:xfrm>
-            <a:off x="3447288" y="2962656"/>
+            <a:off x="3447288" y="2724912"/>
             <a:ext cx="2423160" cy="804672"/>
           </a:xfrm>
           <a:prstGeom prst="rect">
@@ -2882,8 +2882,8 @@
         </p:nvSpPr>
         <p:spPr>
           <a:xfrm>
-            <a:off x="6190488" y="2359152"/>
-            <a:ext cx="2715768" cy="1481328"/>
+            <a:off x="6190488" y="2121408"/>
+            <a:ext cx="2715768" cy="1371600"/>
           </a:xfrm>
           <a:prstGeom prst="rect">
             <a:avLst/>
@@ -2907,7 +2907,7 @@
         </p:nvSpPr>
         <p:spPr>
           <a:xfrm>
-            <a:off x="6336792" y="2432304"/>
+            <a:off x="6336792" y="2194560"/>
             <a:ext cx="548640" cy="274320"/>
           </a:xfrm>
           <a:prstGeom prst="rect">
@@ -2946,7 +2946,7 @@
         </p:nvSpPr>
         <p:spPr>
           <a:xfrm>
-            <a:off x="6336792" y="2706624"/>
+            <a:off x="6336792" y="2468880"/>
             <a:ext cx="2423160" cy="237744"/>
           </a:xfrm>
           <a:prstGeom prst="rect">
@@ -2985,7 +2985,7 @@
         </p:nvSpPr>
         <p:spPr>
           <a:xfrm>
-            <a:off x="6336792" y="2962656"/>
+            <a:off x="6336792" y="2724912"/>
             <a:ext cx="2423160" cy="804672"/>
           </a:xfrm>
           <a:prstGeom prst="rect">
@@ -3030,8 +3030,8 @@
         </p:nvSpPr>
         <p:spPr>
           <a:xfrm>
-            <a:off x="9079992" y="2359152"/>
-            <a:ext cx="2715768" cy="1481328"/>
+            <a:off x="9079992" y="2121408"/>
+            <a:ext cx="2715768" cy="1371600"/>
           </a:xfrm>
           <a:prstGeom prst="rect">
             <a:avLst/>
@@ -3055,7 +3055,7 @@
         </p:nvSpPr>
         <p:spPr>
           <a:xfrm>
-            <a:off x="9226296" y="2432304"/>
+            <a:off x="9226296" y="2194560"/>
             <a:ext cx="548640" cy="274320"/>
           </a:xfrm>
           <a:prstGeom prst="rect">
@@ -3094,7 +3094,7 @@
         </p:nvSpPr>
         <p:spPr>
           <a:xfrm>
-            <a:off x="9226296" y="2706624"/>
+            <a:off x="9226296" y="2468880"/>
             <a:ext cx="2423160" cy="237744"/>
           </a:xfrm>
           <a:prstGeom prst="rect">
@@ -3133,7 +3133,7 @@
         </p:nvSpPr>
         <p:spPr>
           <a:xfrm>
-            <a:off x="9226296" y="2962656"/>
+            <a:off x="9226296" y="2724912"/>
             <a:ext cx="2423160" cy="804672"/>
           </a:xfrm>
           <a:prstGeom prst="rect">
@@ -3170,41 +3170,40 @@
           </a:p>
         </p:txBody>
       </p:sp>
-      <p:sp>
-        <p:nvSpPr>
-          <p:cNvPr id="27" name="Shape 25"/>
-          <p:cNvSpPr/>
-          <p:nvPr/>
-        </p:nvSpPr>
-        <p:spPr>
-          <a:xfrm>
-            <a:off x="411480" y="4023360"/>
-            <a:ext cx="11375136" cy="1188720"/>
-          </a:xfrm>
-          <a:prstGeom prst="rect">
-            <a:avLst/>
-          </a:prstGeom>
-          <a:solidFill>
-            <a:srgbClr val="F4F4F4"/>
-          </a:solidFill>
-          <a:ln w="12700">
-            <a:solidFill>
-              <a:srgbClr val="909090"/>
-            </a:solidFill>
-            <a:prstDash val="dash"/>
-          </a:ln>
-        </p:spPr>
-      </p:sp>
-      <p:sp>
-        <p:nvSpPr>
-          <p:cNvPr id="28" name="Text 26"/>
-          <p:cNvSpPr/>
-          <p:nvPr/>
-        </p:nvSpPr>
-        <p:spPr>
-          <a:xfrm>
-            <a:off x="411480" y="4023360"/>
-            <a:ext cx="11375136" cy="1188720"/>
+      <p:pic>
+        <p:nvPicPr>
+          <p:cNvPr id="27" name="Image 0" descr="/home/user/EATON/comms/img/tool-1-magnet.jpg">    </p:cNvPr>
+          <p:cNvPicPr>
+            <a:picLocks noChangeAspect="1"/>
+          </p:cNvPicPr>
+          <p:nvPr/>
+        </p:nvPicPr>
+        <p:blipFill>
+          <a:blip r:embed="rId1"/>
+          <a:stretch>
+            <a:fillRect/>
+          </a:stretch>
+        </p:blipFill>
+        <p:spPr>
+          <a:xfrm>
+            <a:off x="411480" y="3639312"/>
+            <a:ext cx="3694176" cy="1481328"/>
+          </a:xfrm>
+          <a:prstGeom prst="rect">
+            <a:avLst/>
+          </a:prstGeom>
+        </p:spPr>
+      </p:pic>
+      <p:sp>
+        <p:nvSpPr>
+          <p:cNvPr id="28" name="Text 25"/>
+          <p:cNvSpPr/>
+          <p:nvPr/>
+        </p:nvSpPr>
+        <p:spPr>
+          <a:xfrm>
+            <a:off x="411480" y="5148072"/>
+            <a:ext cx="3694176" cy="182880"/>
           </a:xfrm>
           <a:prstGeom prst="rect">
             <a:avLst/>
@@ -3220,30 +3219,156 @@
               <a:buNone/>
             </a:pPr>
             <a:r>
-              <a:rPr lang="en-US" sz="1100" dirty="0">
-                <a:solidFill>
-                  <a:srgbClr val="777777"/>
-                </a:solidFill>
-                <a:latin typeface="Arial" pitchFamily="34" charset="0"/>
-                <a:ea typeface="Arial" pitchFamily="34" charset="-122"/>
-                <a:cs typeface="Arial" pitchFamily="34" charset="-120"/>
-              </a:rPr>
-              <a:t>Photo — the three approved hand tools, left to right: magnet, orange push bar, tongs</a:t>
-            </a:r>
-            <a:endParaRPr lang="en-US" sz="1100" dirty="0"/>
-          </a:p>
-        </p:txBody>
-      </p:sp>
-      <p:sp>
-        <p:nvSpPr>
-          <p:cNvPr id="29" name="Shape 27"/>
-          <p:cNvSpPr/>
-          <p:nvPr/>
-        </p:nvSpPr>
-        <p:spPr>
-          <a:xfrm>
-            <a:off x="411480" y="5340096"/>
-            <a:ext cx="11375136" cy="877824"/>
+              <a:rPr lang="en-US" sz="1000" b="1" dirty="0">
+                <a:solidFill>
+                  <a:srgbClr val="000000"/>
+                </a:solidFill>
+                <a:latin typeface="Arial" pitchFamily="34" charset="0"/>
+                <a:ea typeface="Arial" pitchFamily="34" charset="-122"/>
+                <a:cs typeface="Arial" pitchFamily="34" charset="-120"/>
+              </a:rPr>
+              <a:t>1 · MAGNET</a:t>
+            </a:r>
+            <a:endParaRPr lang="en-US" sz="1000" dirty="0"/>
+          </a:p>
+        </p:txBody>
+      </p:sp>
+      <p:pic>
+        <p:nvPicPr>
+          <p:cNvPr id="29" name="Image 1" descr="/home/user/EATON/comms/img/tool-2-push-bar.jpg">    </p:cNvPr>
+          <p:cNvPicPr>
+            <a:picLocks noChangeAspect="1"/>
+          </p:cNvPicPr>
+          <p:nvPr/>
+        </p:nvPicPr>
+        <p:blipFill>
+          <a:blip r:embed="rId2"/>
+          <a:stretch>
+            <a:fillRect/>
+          </a:stretch>
+        </p:blipFill>
+        <p:spPr>
+          <a:xfrm>
+            <a:off x="4251960" y="3639312"/>
+            <a:ext cx="3694176" cy="1481328"/>
+          </a:xfrm>
+          <a:prstGeom prst="rect">
+            <a:avLst/>
+          </a:prstGeom>
+        </p:spPr>
+      </p:pic>
+      <p:sp>
+        <p:nvSpPr>
+          <p:cNvPr id="30" name="Text 26"/>
+          <p:cNvSpPr/>
+          <p:nvPr/>
+        </p:nvSpPr>
+        <p:spPr>
+          <a:xfrm>
+            <a:off x="4251960" y="5148072"/>
+            <a:ext cx="3694176" cy="182880"/>
+          </a:xfrm>
+          <a:prstGeom prst="rect">
+            <a:avLst/>
+          </a:prstGeom>
+          <a:noFill/>
+          <a:ln/>
+        </p:spPr>
+        <p:txBody>
+          <a:bodyPr wrap="square" lIns="0" tIns="0" rIns="0" bIns="0" rtlCol="0" anchor="ctr"/>
+          <a:lstStyle/>
+          <a:p>
+            <a:pPr algn="ctr" indent="0" marL="0">
+              <a:buNone/>
+            </a:pPr>
+            <a:r>
+              <a:rPr lang="en-US" sz="1000" b="1" dirty="0">
+                <a:solidFill>
+                  <a:srgbClr val="000000"/>
+                </a:solidFill>
+                <a:latin typeface="Arial" pitchFamily="34" charset="0"/>
+                <a:ea typeface="Arial" pitchFamily="34" charset="-122"/>
+                <a:cs typeface="Arial" pitchFamily="34" charset="-120"/>
+              </a:rPr>
+              <a:t>2 · ORANGE PUSH BAR</a:t>
+            </a:r>
+            <a:endParaRPr lang="en-US" sz="1000" dirty="0"/>
+          </a:p>
+        </p:txBody>
+      </p:sp>
+      <p:pic>
+        <p:nvPicPr>
+          <p:cNvPr id="31" name="Image 2" descr="/home/user/EATON/comms/img/tool-3-tongs.jpg">    </p:cNvPr>
+          <p:cNvPicPr>
+            <a:picLocks noChangeAspect="1"/>
+          </p:cNvPicPr>
+          <p:nvPr/>
+        </p:nvPicPr>
+        <p:blipFill>
+          <a:blip r:embed="rId3"/>
+          <a:stretch>
+            <a:fillRect/>
+          </a:stretch>
+        </p:blipFill>
+        <p:spPr>
+          <a:xfrm>
+            <a:off x="8092440" y="3639312"/>
+            <a:ext cx="3694176" cy="1481328"/>
+          </a:xfrm>
+          <a:prstGeom prst="rect">
+            <a:avLst/>
+          </a:prstGeom>
+        </p:spPr>
+      </p:pic>
+      <p:sp>
+        <p:nvSpPr>
+          <p:cNvPr id="32" name="Text 27"/>
+          <p:cNvSpPr/>
+          <p:nvPr/>
+        </p:nvSpPr>
+        <p:spPr>
+          <a:xfrm>
+            <a:off x="8092440" y="5148072"/>
+            <a:ext cx="3694176" cy="182880"/>
+          </a:xfrm>
+          <a:prstGeom prst="rect">
+            <a:avLst/>
+          </a:prstGeom>
+          <a:noFill/>
+          <a:ln/>
+        </p:spPr>
+        <p:txBody>
+          <a:bodyPr wrap="square" lIns="0" tIns="0" rIns="0" bIns="0" rtlCol="0" anchor="ctr"/>
+          <a:lstStyle/>
+          <a:p>
+            <a:pPr algn="ctr" indent="0" marL="0">
+              <a:buNone/>
+            </a:pPr>
+            <a:r>
+              <a:rPr lang="en-US" sz="1000" b="1" dirty="0">
+                <a:solidFill>
+                  <a:srgbClr val="000000"/>
+                </a:solidFill>
+                <a:latin typeface="Arial" pitchFamily="34" charset="0"/>
+                <a:ea typeface="Arial" pitchFamily="34" charset="-122"/>
+                <a:cs typeface="Arial" pitchFamily="34" charset="-120"/>
+              </a:rPr>
+              <a:t>3 · TONGS</a:t>
+            </a:r>
+            <a:endParaRPr lang="en-US" sz="1000" dirty="0"/>
+          </a:p>
+        </p:txBody>
+      </p:sp>
+      <p:sp>
+        <p:nvSpPr>
+          <p:cNvPr id="33" name="Shape 28"/>
+          <p:cNvSpPr/>
+          <p:nvPr/>
+        </p:nvSpPr>
+        <p:spPr>
+          <a:xfrm>
+            <a:off x="411480" y="5376672"/>
+            <a:ext cx="11375136" cy="868680"/>
           </a:xfrm>
           <a:prstGeom prst="rect">
             <a:avLst/>
@@ -3261,13 +3386,13 @@
       </p:sp>
       <p:sp>
         <p:nvSpPr>
-          <p:cNvPr id="30" name="Text 28"/>
-          <p:cNvSpPr/>
-          <p:nvPr/>
-        </p:nvSpPr>
-        <p:spPr>
-          <a:xfrm>
-            <a:off x="603504" y="5413248"/>
+          <p:cNvPr id="34" name="Text 29"/>
+          <p:cNvSpPr/>
+          <p:nvPr/>
+        </p:nvSpPr>
+        <p:spPr>
+          <a:xfrm>
+            <a:off x="603504" y="5449824"/>
             <a:ext cx="3657600" cy="219456"/>
           </a:xfrm>
           <a:prstGeom prst="rect">
@@ -3300,14 +3425,14 @@
       </p:sp>
       <p:sp>
         <p:nvSpPr>
-          <p:cNvPr id="31" name="Text 29"/>
-          <p:cNvSpPr/>
-          <p:nvPr/>
-        </p:nvSpPr>
-        <p:spPr>
-          <a:xfrm>
-            <a:off x="603504" y="5650992"/>
-            <a:ext cx="10972800" cy="512064"/>
+          <p:cNvPr id="35" name="Text 30"/>
+          <p:cNvSpPr/>
+          <p:nvPr/>
+        </p:nvSpPr>
+        <p:spPr>
+          <a:xfrm>
+            <a:off x="603504" y="5669280"/>
+            <a:ext cx="10972800" cy="548640"/>
           </a:xfrm>
           <a:prstGeom prst="rect">
             <a:avLst/>
@@ -3408,7 +3533,7 @@
       </p:sp>
       <p:sp>
         <p:nvSpPr>
-          <p:cNvPr id="32" name="Text 30"/>
+          <p:cNvPr id="36" name="Text 31"/>
           <p:cNvSpPr/>
           <p:nvPr/>
         </p:nvSpPr>
@@ -3447,7 +3572,7 @@
       </p:sp>
       <p:sp>
         <p:nvSpPr>
-          <p:cNvPr id="33" name="Text 31"/>
+          <p:cNvPr id="37" name="Text 32"/>
           <p:cNvSpPr/>
           <p:nvPr/>
         </p:nvSpPr>
@@ -3486,7 +3611,7 @@
       </p:sp>
       <p:sp>
         <p:nvSpPr>
-          <p:cNvPr id="34" name="Shape 32"/>
+          <p:cNvPr id="38" name="Shape 33"/>
           <p:cNvSpPr/>
           <p:nvPr/>
         </p:nvSpPr>
@@ -3506,7 +3631,7 @@
       </p:sp>
       <p:sp>
         <p:nvSpPr>
-          <p:cNvPr id="35" name="Text 33"/>
+          <p:cNvPr id="39" name="Text 34"/>
           <p:cNvSpPr/>
           <p:nvPr/>
         </p:nvSpPr>

</xml_diff>